<commit_message>
Update and reorganize course materials
</commit_message>
<xml_diff>
--- a/AgenticAI/1-Intro-To-AgenticAI/2_Agent_vs_Chatbot_Finance.pptx
+++ b/AgenticAI/1-Intro-To-AgenticAI/2_Agent_vs_Chatbot_Finance.pptx
@@ -221,7 +221,7 @@
           <a:p>
             <a:fld id="{7BAEECA8-D063-486F-AE31-5020270C1449}" type="datetimeFigureOut">
               <a:rPr lang="en-US" smtClean="0"/>
-              <a:t>6/5/2026</a:t>
+              <a:t>9/5/2026</a:t>
             </a:fld>
             <a:endParaRPr lang="en-US"/>
           </a:p>
@@ -398,7 +398,7 @@
           <a:p>
             <a:fld id="{CB233BD1-3BA8-448D-9D08-7846095EA517}" type="datetimeFigureOut">
               <a:rPr lang="en-US" smtClean="0"/>
-              <a:t>6/5/2026</a:t>
+              <a:t>9/5/2026</a:t>
             </a:fld>
             <a:endParaRPr lang="en-US"/>
           </a:p>
@@ -812,7 +812,7 @@
           <a:p>
             <a:fld id="{6383FAE1-13DE-4511-8C1B-C8AFB720664C}" type="datetimeFigureOut">
               <a:rPr lang="en-US" smtClean="0"/>
-              <a:t>6/5/2026</a:t>
+              <a:t>9/5/2026</a:t>
             </a:fld>
             <a:endParaRPr lang="en-US"/>
           </a:p>
@@ -1010,7 +1010,7 @@
           <a:p>
             <a:fld id="{6383FAE1-13DE-4511-8C1B-C8AFB720664C}" type="datetimeFigureOut">
               <a:rPr lang="en-US" smtClean="0"/>
-              <a:t>6/5/2026</a:t>
+              <a:t>9/5/2026</a:t>
             </a:fld>
             <a:endParaRPr lang="en-US"/>
           </a:p>
@@ -1218,7 +1218,7 @@
           <a:p>
             <a:fld id="{6383FAE1-13DE-4511-8C1B-C8AFB720664C}" type="datetimeFigureOut">
               <a:rPr lang="en-US" smtClean="0"/>
-              <a:t>6/5/2026</a:t>
+              <a:t>9/5/2026</a:t>
             </a:fld>
             <a:endParaRPr lang="en-US"/>
           </a:p>
@@ -1416,7 +1416,7 @@
           <a:p>
             <a:fld id="{6383FAE1-13DE-4511-8C1B-C8AFB720664C}" type="datetimeFigureOut">
               <a:rPr lang="en-US" smtClean="0"/>
-              <a:t>6/5/2026</a:t>
+              <a:t>9/5/2026</a:t>
             </a:fld>
             <a:endParaRPr lang="en-US"/>
           </a:p>
@@ -1691,7 +1691,7 @@
           <a:p>
             <a:fld id="{6383FAE1-13DE-4511-8C1B-C8AFB720664C}" type="datetimeFigureOut">
               <a:rPr lang="en-US" smtClean="0"/>
-              <a:t>6/5/2026</a:t>
+              <a:t>9/5/2026</a:t>
             </a:fld>
             <a:endParaRPr lang="en-US"/>
           </a:p>
@@ -1956,7 +1956,7 @@
           <a:p>
             <a:fld id="{6383FAE1-13DE-4511-8C1B-C8AFB720664C}" type="datetimeFigureOut">
               <a:rPr lang="en-US" smtClean="0"/>
-              <a:t>6/5/2026</a:t>
+              <a:t>9/5/2026</a:t>
             </a:fld>
             <a:endParaRPr lang="en-US"/>
           </a:p>
@@ -2368,7 +2368,7 @@
           <a:p>
             <a:fld id="{6383FAE1-13DE-4511-8C1B-C8AFB720664C}" type="datetimeFigureOut">
               <a:rPr lang="en-US" smtClean="0"/>
-              <a:t>6/5/2026</a:t>
+              <a:t>9/5/2026</a:t>
             </a:fld>
             <a:endParaRPr lang="en-US"/>
           </a:p>
@@ -2509,7 +2509,7 @@
           <a:p>
             <a:fld id="{6383FAE1-13DE-4511-8C1B-C8AFB720664C}" type="datetimeFigureOut">
               <a:rPr lang="en-US" smtClean="0"/>
-              <a:t>6/5/2026</a:t>
+              <a:t>9/5/2026</a:t>
             </a:fld>
             <a:endParaRPr lang="en-US"/>
           </a:p>
@@ -2622,7 +2622,7 @@
           <a:p>
             <a:fld id="{6383FAE1-13DE-4511-8C1B-C8AFB720664C}" type="datetimeFigureOut">
               <a:rPr lang="en-US" smtClean="0"/>
-              <a:t>6/5/2026</a:t>
+              <a:t>9/5/2026</a:t>
             </a:fld>
             <a:endParaRPr lang="en-US"/>
           </a:p>
@@ -2933,7 +2933,7 @@
           <a:p>
             <a:fld id="{6383FAE1-13DE-4511-8C1B-C8AFB720664C}" type="datetimeFigureOut">
               <a:rPr lang="en-US" smtClean="0"/>
-              <a:t>6/5/2026</a:t>
+              <a:t>9/5/2026</a:t>
             </a:fld>
             <a:endParaRPr lang="en-US"/>
           </a:p>
@@ -3224,7 +3224,7 @@
           <a:p>
             <a:fld id="{6383FAE1-13DE-4511-8C1B-C8AFB720664C}" type="datetimeFigureOut">
               <a:rPr lang="en-US" smtClean="0"/>
-              <a:t>6/5/2026</a:t>
+              <a:t>9/5/2026</a:t>
             </a:fld>
             <a:endParaRPr lang="en-US"/>
           </a:p>
@@ -3468,7 +3468,7 @@
           <a:p>
             <a:fld id="{6383FAE1-13DE-4511-8C1B-C8AFB720664C}" type="datetimeFigureOut">
               <a:rPr lang="en-US" smtClean="0"/>
-              <a:t>6/5/2026</a:t>
+              <a:t>9/5/2026</a:t>
             </a:fld>
             <a:endParaRPr lang="en-US"/>
           </a:p>
@@ -4245,7 +4245,7 @@
         <p:spPr>
           <a:xfrm>
             <a:off x="64008" y="153198"/>
-            <a:ext cx="11018520" cy="6001643"/>
+            <a:ext cx="11018520" cy="5632311"/>
           </a:xfrm>
           <a:prstGeom prst="rect">
             <a:avLst/>
@@ -4357,10 +4357,16 @@
                   </a:schemeClr>
                 </a:solidFill>
               </a:rPr>
-              <a:t>"For account security, press 1 for password reset, press 2 to speak to an agent."</a:t>
-            </a:r>
-            <a:r>
-              <a:rPr lang="en-US" sz="2400" dirty="0">
+              <a:t>"For account security, </a:t>
+            </a:r>
+          </a:p>
+          <a:p>
+            <a:pPr marL="342900" indent="-342900">
+              <a:buFont typeface="Arial" panose="020B0604020202020204" pitchFamily="34" charset="0"/>
+              <a:buChar char="•"/>
+            </a:pPr>
+            <a:r>
+              <a:rPr lang="en-US" sz="2400" i="1" dirty="0">
                 <a:solidFill>
                   <a:schemeClr val="accent6">
                     <a:lumMod val="60000"/>
@@ -4368,28 +4374,16 @@
                   </a:schemeClr>
                 </a:solidFill>
               </a:rPr>
-              <a:t> </a:t>
-            </a:r>
-          </a:p>
-          <a:p>
-            <a:pPr>
-              <a:buNone/>
+              <a:t>press 1 for password reset, </a:t>
+            </a:r>
+          </a:p>
+          <a:p>
+            <a:pPr marL="342900" indent="-342900">
+              <a:buFont typeface="Arial" panose="020B0604020202020204" pitchFamily="34" charset="0"/>
+              <a:buChar char="•"/>
             </a:pPr>
-            <a:endParaRPr lang="en-US" sz="2400" dirty="0">
-              <a:solidFill>
-                <a:schemeClr val="accent6">
-                  <a:lumMod val="60000"/>
-                  <a:lumOff val="40000"/>
-                </a:schemeClr>
-              </a:solidFill>
-            </a:endParaRPr>
-          </a:p>
-          <a:p>
-            <a:pPr>
-              <a:buNone/>
-            </a:pPr>
-            <a:r>
-              <a:rPr lang="en-US" sz="2400" dirty="0">
+            <a:r>
+              <a:rPr lang="en-US" sz="2400" i="1" dirty="0">
                 <a:solidFill>
                   <a:schemeClr val="accent6">
                     <a:lumMod val="60000"/>
@@ -4397,21 +4391,32 @@
                   </a:schemeClr>
                 </a:solidFill>
               </a:rPr>
-              <a:t>That's it. Ask it something slightly differently — "my account seems compromised" — and it might return a generic  "I didn't understand that.“</a:t>
-            </a:r>
-          </a:p>
-          <a:p>
-            <a:pPr>
-              <a:buNone/>
-            </a:pPr>
-            <a:endParaRPr lang="en-US" sz="2400" dirty="0">
-              <a:solidFill>
-                <a:schemeClr val="accent6">
-                  <a:lumMod val="60000"/>
-                  <a:lumOff val="40000"/>
-                </a:schemeClr>
-              </a:solidFill>
-            </a:endParaRPr>
+              <a:t>press 2 to speak to an agent.</a:t>
+            </a:r>
+          </a:p>
+          <a:p>
+            <a:r>
+              <a:rPr lang="en-US" sz="2400" i="1" dirty="0">
+                <a:solidFill>
+                  <a:schemeClr val="accent6">
+                    <a:lumMod val="60000"/>
+                    <a:lumOff val="40000"/>
+                  </a:schemeClr>
+                </a:solidFill>
+              </a:rPr>
+              <a:t>"</a:t>
+            </a:r>
+            <a:r>
+              <a:rPr lang="en-US" sz="2400" dirty="0">
+                <a:solidFill>
+                  <a:schemeClr val="accent6">
+                    <a:lumMod val="60000"/>
+                    <a:lumOff val="40000"/>
+                  </a:schemeClr>
+                </a:solidFill>
+              </a:rPr>
+              <a:t> </a:t>
+            </a:r>
           </a:p>
           <a:p>
             <a:pPr>
@@ -4594,7 +4599,18 @@
                   </a:schemeClr>
                 </a:solidFill>
               </a:rPr>
-              <a:t> anything – no action</a:t>
+              <a:t> anything – </a:t>
+            </a:r>
+            <a:r>
+              <a:rPr lang="en-US" sz="2400" b="1" i="1" u="sng" dirty="0">
+                <a:solidFill>
+                  <a:schemeClr val="accent6">
+                    <a:lumMod val="60000"/>
+                    <a:lumOff val="40000"/>
+                  </a:schemeClr>
+                </a:solidFill>
+              </a:rPr>
+              <a:t>no action</a:t>
             </a:r>
           </a:p>
           <a:p>
@@ -4850,8 +4866,8 @@
         </p:nvSpPr>
         <p:spPr>
           <a:xfrm>
-            <a:off x="3520440" y="5650992"/>
-            <a:ext cx="3694176" cy="868680"/>
+            <a:off x="3842004" y="5416177"/>
+            <a:ext cx="4507992" cy="1197864"/>
           </a:xfrm>
           <a:prstGeom prst="ellipse">
             <a:avLst/>
@@ -4880,7 +4896,14 @@
             <a:pPr algn="ctr"/>
             <a:r>
               <a:rPr lang="en-US" sz="2400" dirty="0"/>
-              <a:t>LLM + Tools = Agents</a:t>
+              <a:t>Agents =</a:t>
+            </a:r>
+          </a:p>
+          <a:p>
+            <a:pPr algn="ctr"/>
+            <a:r>
+              <a:rPr lang="en-US" sz="2400" dirty="0"/>
+              <a:t>LLM + Tools + Memory </a:t>
             </a:r>
           </a:p>
         </p:txBody>
@@ -4945,7 +4968,18 @@
                   </a:schemeClr>
                 </a:solidFill>
               </a:rPr>
-              <a:t>The agent understands language like the LLM chatbot — but it also can perform actions </a:t>
+              <a:t>The agent understands language like the LLM chatbot — but it also can </a:t>
+            </a:r>
+            <a:r>
+              <a:rPr lang="en-US" sz="2400" b="1" i="1" u="sng" dirty="0">
+                <a:solidFill>
+                  <a:schemeClr val="accent6">
+                    <a:lumMod val="60000"/>
+                    <a:lumOff val="40000"/>
+                  </a:schemeClr>
+                </a:solidFill>
+              </a:rPr>
+              <a:t>perform actions </a:t>
             </a:r>
           </a:p>
           <a:p>
@@ -5239,7 +5273,7 @@
                   </a:schemeClr>
                 </a:solidFill>
               </a:rPr>
-              <a:t>Example: </a:t>
+              <a:t>Summarize with an example: </a:t>
             </a:r>
           </a:p>
           <a:p>
@@ -5317,7 +5351,7 @@
         </p:blipFill>
         <p:spPr>
           <a:xfrm>
-            <a:off x="3590545" y="1207747"/>
+            <a:off x="3657974" y="1235179"/>
             <a:ext cx="3185930" cy="4709635"/>
           </a:xfrm>
           <a:prstGeom prst="rect">
@@ -5546,168 +5580,6 @@
           <a:chExt cx="0" cy="0"/>
         </a:xfrm>
       </p:grpSpPr>
-      <p:sp>
-        <p:nvSpPr>
-          <p:cNvPr id="2" name="Title 1">
-            <a:extLst>
-              <a:ext uri="{FF2B5EF4-FFF2-40B4-BE49-F238E27FC236}">
-                <a16:creationId xmlns:a16="http://schemas.microsoft.com/office/drawing/2014/main" id="{795E1B75-886E-0812-B2FD-DD250C225521}"/>
-              </a:ext>
-            </a:extLst>
-          </p:cNvPr>
-          <p:cNvSpPr>
-            <a:spLocks noGrp="1"/>
-          </p:cNvSpPr>
-          <p:nvPr>
-            <p:ph type="title"/>
-          </p:nvPr>
-        </p:nvSpPr>
-        <p:spPr>
-          <a:xfrm>
-            <a:off x="274320" y="136525"/>
-            <a:ext cx="11466576" cy="832739"/>
-          </a:xfrm>
-        </p:spPr>
-        <p:txBody>
-          <a:bodyPr>
-            <a:normAutofit/>
-          </a:bodyPr>
-          <a:lstStyle/>
-          <a:p>
-            <a:r>
-              <a:rPr lang="en-US" sz="3600" dirty="0"/>
-              <a:t>EXTRA</a:t>
-            </a:r>
-          </a:p>
-        </p:txBody>
-      </p:sp>
-      <p:sp>
-        <p:nvSpPr>
-          <p:cNvPr id="4" name="TextBox 3">
-            <a:extLst>
-              <a:ext uri="{FF2B5EF4-FFF2-40B4-BE49-F238E27FC236}">
-                <a16:creationId xmlns:a16="http://schemas.microsoft.com/office/drawing/2014/main" id="{902F8BE4-9CEA-0DAD-0357-E0A8215F169D}"/>
-              </a:ext>
-            </a:extLst>
-          </p:cNvPr>
-          <p:cNvSpPr txBox="1"/>
-          <p:nvPr/>
-        </p:nvSpPr>
-        <p:spPr>
-          <a:xfrm>
-            <a:off x="274320" y="933117"/>
-            <a:ext cx="11658600" cy="1477328"/>
-          </a:xfrm>
-          <a:prstGeom prst="rect">
-            <a:avLst/>
-          </a:prstGeom>
-          <a:noFill/>
-        </p:spPr>
-        <p:txBody>
-          <a:bodyPr wrap="square">
-            <a:spAutoFit/>
-          </a:bodyPr>
-          <a:lstStyle/>
-          <a:p>
-            <a:pPr marL="0" indent="0">
-              <a:buNone/>
-            </a:pPr>
-            <a:r>
-              <a:rPr lang="en-US" dirty="0" err="1">
-                <a:solidFill>
-                  <a:schemeClr val="accent6">
-                    <a:lumMod val="60000"/>
-                    <a:lumOff val="40000"/>
-                  </a:schemeClr>
-                </a:solidFill>
-              </a:rPr>
-              <a:t>Ffnbksdfd</a:t>
-            </a:r>
-            <a:endParaRPr lang="en-US" dirty="0">
-              <a:solidFill>
-                <a:schemeClr val="accent6">
-                  <a:lumMod val="60000"/>
-                  <a:lumOff val="40000"/>
-                </a:schemeClr>
-              </a:solidFill>
-            </a:endParaRPr>
-          </a:p>
-          <a:p>
-            <a:pPr marL="0" indent="0">
-              <a:buNone/>
-            </a:pPr>
-            <a:r>
-              <a:rPr lang="en-US" dirty="0" err="1">
-                <a:solidFill>
-                  <a:schemeClr val="accent6">
-                    <a:lumMod val="60000"/>
-                    <a:lumOff val="40000"/>
-                  </a:schemeClr>
-                </a:solidFill>
-              </a:rPr>
-              <a:t>Fdslj;f</a:t>
-            </a:r>
-            <a:endParaRPr lang="en-US" dirty="0">
-              <a:solidFill>
-                <a:schemeClr val="accent6">
-                  <a:lumMod val="60000"/>
-                  <a:lumOff val="40000"/>
-                </a:schemeClr>
-              </a:solidFill>
-            </a:endParaRPr>
-          </a:p>
-          <a:p>
-            <a:pPr marL="0" indent="0">
-              <a:buNone/>
-            </a:pPr>
-            <a:endParaRPr lang="en-US" dirty="0">
-              <a:solidFill>
-                <a:schemeClr val="accent6">
-                  <a:lumMod val="60000"/>
-                  <a:lumOff val="40000"/>
-                </a:schemeClr>
-              </a:solidFill>
-            </a:endParaRPr>
-          </a:p>
-          <a:p>
-            <a:pPr marL="0" indent="0">
-              <a:buNone/>
-            </a:pPr>
-            <a:r>
-              <a:rPr lang="en-US" dirty="0" err="1">
-                <a:solidFill>
-                  <a:schemeClr val="accent6">
-                    <a:lumMod val="60000"/>
-                    <a:lumOff val="40000"/>
-                  </a:schemeClr>
-                </a:solidFill>
-              </a:rPr>
-              <a:t>Fl;ds</a:t>
-            </a:r>
-            <a:endParaRPr lang="en-US" dirty="0">
-              <a:solidFill>
-                <a:schemeClr val="accent6">
-                  <a:lumMod val="60000"/>
-                  <a:lumOff val="40000"/>
-                </a:schemeClr>
-              </a:solidFill>
-            </a:endParaRPr>
-          </a:p>
-          <a:p>
-            <a:pPr marL="0" indent="0">
-              <a:buNone/>
-            </a:pPr>
-            <a:endParaRPr lang="en-US" dirty="0">
-              <a:solidFill>
-                <a:schemeClr val="accent6">
-                  <a:lumMod val="60000"/>
-                  <a:lumOff val="40000"/>
-                </a:schemeClr>
-              </a:solidFill>
-            </a:endParaRPr>
-          </a:p>
-        </p:txBody>
-      </p:sp>
     </p:spTree>
     <p:extLst>
       <p:ext uri="{BB962C8B-B14F-4D97-AF65-F5344CB8AC3E}">

</xml_diff>